<commit_message>
feat: Final project deliverables (PDFs, PPTX, data leakage fix)
</commit_message>
<xml_diff>
--- a/docs/slides.pptx
+++ b/docs/slides.pptx
@@ -17,8 +17,25 @@
     <p:sldId id="265" r:id="rId16"/>
     <p:sldId id="266" r:id="rId17"/>
     <p:sldId id="267" r:id="rId18"/>
+    <p:sldId id="268" r:id="rId19"/>
+    <p:sldId id="269" r:id="rId20"/>
+    <p:sldId id="270" r:id="rId21"/>
+    <p:sldId id="271" r:id="rId22"/>
+    <p:sldId id="272" r:id="rId23"/>
+    <p:sldId id="273" r:id="rId24"/>
+    <p:sldId id="274" r:id="rId25"/>
+    <p:sldId id="275" r:id="rId26"/>
+    <p:sldId id="276" r:id="rId27"/>
+    <p:sldId id="277" r:id="rId28"/>
+    <p:sldId id="278" r:id="rId29"/>
+    <p:sldId id="279" r:id="rId30"/>
+    <p:sldId id="280" r:id="rId31"/>
+    <p:sldId id="281" r:id="rId32"/>
+    <p:sldId id="282" r:id="rId33"/>
+    <p:sldId id="283" r:id="rId34"/>
+    <p:sldId id="284" r:id="rId35"/>
   </p:sldIdLst>
-  <p:sldSz cx="12191695" cy="6858000" type="screen4x3"/>
+  <p:sldSz cx="9144000" cy="6858000" type="screen4x3"/>
   <p:notesSz cx="6858000" cy="9144000"/>
   <p:defaultTextStyle>
     <a:defPPr>
@@ -3099,72 +3116,30 @@
         <p:nvPr/>
       </p:nvGrpSpPr>
       <p:grpSpPr/>
-      <p:sp>
-        <p:nvSpPr>
-          <p:cNvPr id="2" name="Title 1"/>
-          <p:cNvSpPr>
-            <a:spLocks noGrp="1"/>
-          </p:cNvSpPr>
-          <p:nvPr>
-            <p:ph type="ctrTitle"/>
-          </p:nvPr>
-        </p:nvSpPr>
-        <p:spPr/>
-        <p:txBody>
-          <a:bodyPr/>
-          <a:lstStyle/>
-          <a:p>
-            <a:pPr>
-              <a:defRPr sz="4400">
-                <a:solidFill>
-                  <a:srgbClr val="1A1A2E"/>
-                </a:solidFill>
-              </a:defRPr>
-            </a:pPr>
-            <a:r>
-              <a:t>Predicting Customer Order Value</a:t>
-            </a:r>
-          </a:p>
-          <a:p>
-            <a:r>
-              <a:t>for an E-Commerce Platform</a:t>
-            </a:r>
-          </a:p>
-        </p:txBody>
-      </p:sp>
-      <p:sp>
-        <p:nvSpPr>
-          <p:cNvPr id="3" name="Subtitle 2"/>
-          <p:cNvSpPr>
-            <a:spLocks noGrp="1"/>
-          </p:cNvSpPr>
-          <p:nvPr>
-            <p:ph type="subTitle" idx="1"/>
-          </p:nvPr>
-        </p:nvSpPr>
-        <p:spPr/>
-        <p:txBody>
-          <a:bodyPr/>
-          <a:lstStyle/>
-          <a:p>
-            <a:pPr>
-              <a:defRPr sz="2400">
-                <a:solidFill>
-                  <a:srgbClr val="0096D6"/>
-                </a:solidFill>
-              </a:defRPr>
-            </a:pPr>
-            <a:r>
-              <a:t>Business Analytics — Final Project</a:t>
-            </a:r>
-          </a:p>
-          <a:p>
-            <a:r>
-              <a:t>XGBoost R²=0.70 | 180 Features | 43 Tests</a:t>
-            </a:r>
-          </a:p>
-        </p:txBody>
-      </p:sp>
+      <p:pic>
+        <p:nvPicPr>
+          <p:cNvPr id="2" name="Picture 1" descr="slide-01.png"/>
+          <p:cNvPicPr>
+            <a:picLocks noChangeAspect="1"/>
+          </p:cNvPicPr>
+          <p:nvPr/>
+        </p:nvPicPr>
+        <p:blipFill>
+          <a:blip r:embed="rId2"/>
+          <a:stretch>
+            <a:fillRect/>
+          </a:stretch>
+        </p:blipFill>
+        <p:spPr>
+          <a:xfrm>
+            <a:off x="0" y="0"/>
+            <a:ext cx="9144000" cy="6858000"/>
+          </a:xfrm>
+          <a:prstGeom prst="rect">
+            <a:avLst/>
+          </a:prstGeom>
+        </p:spPr>
+      </p:pic>
     </p:spTree>
   </p:cSld>
   <p:clrMapOvr>
@@ -3183,150 +3158,30 @@
         <p:nvPr/>
       </p:nvGrpSpPr>
       <p:grpSpPr/>
-      <p:sp>
-        <p:nvSpPr>
-          <p:cNvPr id="2" name="Title 1"/>
-          <p:cNvSpPr>
-            <a:spLocks noGrp="1"/>
-          </p:cNvSpPr>
-          <p:nvPr>
-            <p:ph type="title"/>
-          </p:nvPr>
-        </p:nvSpPr>
-        <p:spPr/>
-        <p:txBody>
-          <a:bodyPr/>
-          <a:lstStyle/>
-          <a:p>
-            <a:pPr>
-              <a:defRPr sz="3600">
-                <a:solidFill>
-                  <a:srgbClr val="1A1A2E"/>
-                </a:solidFill>
-              </a:defRPr>
-            </a:pPr>
-            <a:r>
-              <a:t>Business Recommendations</a:t>
-            </a:r>
-          </a:p>
-        </p:txBody>
-      </p:sp>
-      <p:sp>
-        <p:nvSpPr>
-          <p:cNvPr id="3" name="Content Placeholder 2"/>
-          <p:cNvSpPr>
-            <a:spLocks noGrp="1"/>
-          </p:cNvSpPr>
-          <p:nvPr>
-            <p:ph idx="1"/>
-          </p:nvPr>
-        </p:nvSpPr>
-        <p:spPr/>
-        <p:txBody>
-          <a:bodyPr/>
-          <a:lstStyle/>
-          <a:p>
-            <a:pPr>
-              <a:defRPr sz="2000"/>
-            </a:pPr>
-            <a:r>
-              <a:t>1. Loyalty Upgrade Campaigns</a:t>
-            </a:r>
-          </a:p>
-          <a:p>
-            <a:pPr>
-              <a:defRPr sz="2000"/>
-            </a:pPr>
-            <a:r>
-              <a:t>   2.5× AOV spread — target bronze with upgrade incentives</a:t>
-            </a:r>
-          </a:p>
-          <a:p>
-            <a:pPr>
-              <a:defRPr sz="2000"/>
-            </a:pPr>
-          </a:p>
-          <a:p>
-            <a:pPr>
-              <a:defRPr sz="2000"/>
-            </a:pPr>
-            <a:r>
-              <a:t>2. Email Channel Investment</a:t>
-            </a:r>
-          </a:p>
-          <a:p>
-            <a:pPr>
-              <a:defRPr sz="2000"/>
-            </a:pPr>
-            <a:r>
-              <a:t>   64% AOV premium — email subscribers = high-intent customers</a:t>
-            </a:r>
-          </a:p>
-          <a:p>
-            <a:pPr>
-              <a:defRPr sz="2000"/>
-            </a:pPr>
-          </a:p>
-          <a:p>
-            <a:pPr>
-              <a:defRPr sz="2000"/>
-            </a:pPr>
-            <a:r>
-              <a:t>3. Desktop-Optimized Checkout</a:t>
-            </a:r>
-          </a:p>
-          <a:p>
-            <a:pPr>
-              <a:defRPr sz="2000"/>
-            </a:pPr>
-            <a:r>
-              <a:t>   7% higher median — invest in desktop UX for high-value categories</a:t>
-            </a:r>
-          </a:p>
-          <a:p>
-            <a:pPr>
-              <a:defRPr sz="2000"/>
-            </a:pPr>
-          </a:p>
-          <a:p>
-            <a:pPr>
-              <a:defRPr sz="2000"/>
-            </a:pPr>
-            <a:r>
-              <a:t>4. Real-Time Cart Upsell</a:t>
-            </a:r>
-          </a:p>
-          <a:p>
-            <a:pPr>
-              <a:defRPr sz="2000"/>
-            </a:pPr>
-            <a:r>
-              <a:t>   Cart additions = #3 feature — trigger recs for low-engagement sessions</a:t>
-            </a:r>
-          </a:p>
-          <a:p>
-            <a:pPr>
-              <a:defRPr sz="2000"/>
-            </a:pPr>
-          </a:p>
-          <a:p>
-            <a:pPr>
-              <a:defRPr sz="2000"/>
-            </a:pPr>
-            <a:r>
-              <a:t>5. Income-Based Personalization</a:t>
-            </a:r>
-          </a:p>
-          <a:p>
-            <a:pPr>
-              <a:defRPr sz="2000"/>
-            </a:pPr>
-            <a:r>
-              <a:t>   income × loyalty = #1 feature — personalize by predicted spending tier</a:t>
-            </a:r>
-          </a:p>
-        </p:txBody>
-      </p:sp>
+      <p:pic>
+        <p:nvPicPr>
+          <p:cNvPr id="2" name="Picture 1" descr="slide-10.png"/>
+          <p:cNvPicPr>
+            <a:picLocks noChangeAspect="1"/>
+          </p:cNvPicPr>
+          <p:nvPr/>
+        </p:nvPicPr>
+        <p:blipFill>
+          <a:blip r:embed="rId2"/>
+          <a:stretch>
+            <a:fillRect/>
+          </a:stretch>
+        </p:blipFill>
+        <p:spPr>
+          <a:xfrm>
+            <a:off x="0" y="0"/>
+            <a:ext cx="9144000" cy="6858000"/>
+          </a:xfrm>
+          <a:prstGeom prst="rect">
+            <a:avLst/>
+          </a:prstGeom>
+        </p:spPr>
+      </p:pic>
     </p:spTree>
   </p:cSld>
   <p:clrMapOvr>
@@ -3345,143 +3200,30 @@
         <p:nvPr/>
       </p:nvGrpSpPr>
       <p:grpSpPr/>
-      <p:sp>
-        <p:nvSpPr>
-          <p:cNvPr id="2" name="Title 1"/>
-          <p:cNvSpPr>
-            <a:spLocks noGrp="1"/>
-          </p:cNvSpPr>
-          <p:nvPr>
-            <p:ph type="title"/>
-          </p:nvPr>
-        </p:nvSpPr>
-        <p:spPr/>
-        <p:txBody>
-          <a:bodyPr/>
-          <a:lstStyle/>
-          <a:p>
-            <a:pPr>
-              <a:defRPr sz="3600">
-                <a:solidFill>
-                  <a:srgbClr val="1A1A2E"/>
-                </a:solidFill>
-              </a:defRPr>
-            </a:pPr>
-            <a:r>
-              <a:t>Limitations &amp; Future Work</a:t>
-            </a:r>
-          </a:p>
-        </p:txBody>
-      </p:sp>
-      <p:sp>
-        <p:nvSpPr>
-          <p:cNvPr id="3" name="Content Placeholder 2"/>
-          <p:cNvSpPr>
-            <a:spLocks noGrp="1"/>
-          </p:cNvSpPr>
-          <p:nvPr>
-            <p:ph idx="1"/>
-          </p:nvPr>
-        </p:nvSpPr>
-        <p:spPr/>
-        <p:txBody>
-          <a:bodyPr/>
-          <a:lstStyle/>
-          <a:p>
-            <a:pPr>
-              <a:defRPr sz="2000"/>
-            </a:pPr>
-            <a:r>
-              <a:t>Limitations:</a:t>
-            </a:r>
-          </a:p>
-          <a:p>
-            <a:pPr>
-              <a:defRPr sz="2000"/>
-            </a:pPr>
-            <a:r>
-              <a:t>  • Synthetic correlations are simulated, not observed</a:t>
-            </a:r>
-          </a:p>
-          <a:p>
-            <a:pPr>
-              <a:defRPr sz="2000"/>
-            </a:pPr>
-            <a:r>
-              <a:t>  • KPI targets not met (MAE R$43 vs R$25 target)</a:t>
-            </a:r>
-          </a:p>
-          <a:p>
-            <a:pPr>
-              <a:defRPr sz="2000"/>
-            </a:pPr>
-            <a:r>
-              <a:t>  • No product-level pricing features</a:t>
-            </a:r>
-          </a:p>
-          <a:p>
-            <a:pPr>
-              <a:defRPr sz="2000"/>
-            </a:pPr>
-            <a:r>
-              <a:t>  • 97% of customers have only 1 order</a:t>
-            </a:r>
-          </a:p>
-          <a:p>
-            <a:pPr>
-              <a:defRPr sz="2000"/>
-            </a:pPr>
-          </a:p>
-          <a:p>
-            <a:pPr>
-              <a:defRPr sz="2000"/>
-            </a:pPr>
-            <a:r>
-              <a:t>Future Work:</a:t>
-            </a:r>
-          </a:p>
-          <a:p>
-            <a:pPr>
-              <a:defRPr sz="2000"/>
-            </a:pPr>
-            <a:r>
-              <a:t>  • Real clickstream data to validate simulation</a:t>
-            </a:r>
-          </a:p>
-          <a:p>
-            <a:pPr>
-              <a:defRPr sz="2000"/>
-            </a:pPr>
-            <a:r>
-              <a:t>  • Sequence modeling (LSTM/Transformer) for clickstream</a:t>
-            </a:r>
-          </a:p>
-          <a:p>
-            <a:pPr>
-              <a:defRPr sz="2000"/>
-            </a:pPr>
-            <a:r>
-              <a:t>  • Feature store for real-time prediction</a:t>
-            </a:r>
-          </a:p>
-          <a:p>
-            <a:pPr>
-              <a:defRPr sz="2000"/>
-            </a:pPr>
-            <a:r>
-              <a:t>  • Customer lifetime value (CLV) extension</a:t>
-            </a:r>
-          </a:p>
-          <a:p>
-            <a:pPr>
-              <a:defRPr sz="2000"/>
-            </a:pPr>
-            <a:r>
-              <a:t>  • Product-level pricing from external sources</a:t>
-            </a:r>
-          </a:p>
-        </p:txBody>
-      </p:sp>
+      <p:pic>
+        <p:nvPicPr>
+          <p:cNvPr id="2" name="Picture 1" descr="slide-11.png"/>
+          <p:cNvPicPr>
+            <a:picLocks noChangeAspect="1"/>
+          </p:cNvPicPr>
+          <p:nvPr/>
+        </p:nvPicPr>
+        <p:blipFill>
+          <a:blip r:embed="rId2"/>
+          <a:stretch>
+            <a:fillRect/>
+          </a:stretch>
+        </p:blipFill>
+        <p:spPr>
+          <a:xfrm>
+            <a:off x="0" y="0"/>
+            <a:ext cx="9144000" cy="6858000"/>
+          </a:xfrm>
+          <a:prstGeom prst="rect">
+            <a:avLst/>
+          </a:prstGeom>
+        </p:spPr>
+      </p:pic>
     </p:spTree>
   </p:cSld>
   <p:clrMapOvr>
@@ -3500,78 +3242,324 @@
         <p:nvPr/>
       </p:nvGrpSpPr>
       <p:grpSpPr/>
-      <p:sp>
-        <p:nvSpPr>
-          <p:cNvPr id="2" name="Title 1"/>
-          <p:cNvSpPr>
-            <a:spLocks noGrp="1"/>
-          </p:cNvSpPr>
-          <p:nvPr>
-            <p:ph type="ctrTitle"/>
-          </p:nvPr>
-        </p:nvSpPr>
-        <p:spPr/>
-        <p:txBody>
-          <a:bodyPr/>
-          <a:lstStyle/>
-          <a:p>
-            <a:pPr>
-              <a:defRPr sz="4400">
-                <a:solidFill>
-                  <a:srgbClr val="1A1A2E"/>
-                </a:solidFill>
-              </a:defRPr>
-            </a:pPr>
-            <a:r>
-              <a:t>Thank You</a:t>
-            </a:r>
-          </a:p>
-        </p:txBody>
-      </p:sp>
-      <p:sp>
-        <p:nvSpPr>
-          <p:cNvPr id="3" name="Subtitle 2"/>
-          <p:cNvSpPr>
-            <a:spLocks noGrp="1"/>
-          </p:cNvSpPr>
-          <p:nvPr>
-            <p:ph type="subTitle" idx="1"/>
-          </p:nvPr>
-        </p:nvSpPr>
-        <p:spPr/>
-        <p:txBody>
-          <a:bodyPr/>
-          <a:lstStyle/>
-          <a:p>
-            <a:pPr>
-              <a:defRPr sz="2400">
-                <a:solidFill>
-                  <a:srgbClr val="0096D6"/>
-                </a:solidFill>
-              </a:defRPr>
-            </a:pPr>
-            <a:r>
-              <a:t>Questions?</a:t>
-            </a:r>
-          </a:p>
-          <a:p/>
-          <a:p>
-            <a:r>
-              <a:t>Code: github.com/alitonia/customer_value_prediction</a:t>
-            </a:r>
-          </a:p>
-          <a:p>
-            <a:r>
-              <a:t>Board: github.com/users/alitonia/projects/5</a:t>
-            </a:r>
-          </a:p>
-          <a:p>
-            <a:r>
-              <a:t>Tag: v1.0.0</a:t>
-            </a:r>
-          </a:p>
-        </p:txBody>
-      </p:sp>
+      <p:pic>
+        <p:nvPicPr>
+          <p:cNvPr id="2" name="Picture 1" descr="slide-12.png"/>
+          <p:cNvPicPr>
+            <a:picLocks noChangeAspect="1"/>
+          </p:cNvPicPr>
+          <p:nvPr/>
+        </p:nvPicPr>
+        <p:blipFill>
+          <a:blip r:embed="rId2"/>
+          <a:stretch>
+            <a:fillRect/>
+          </a:stretch>
+        </p:blipFill>
+        <p:spPr>
+          <a:xfrm>
+            <a:off x="0" y="0"/>
+            <a:ext cx="9144000" cy="6858000"/>
+          </a:xfrm>
+          <a:prstGeom prst="rect">
+            <a:avLst/>
+          </a:prstGeom>
+        </p:spPr>
+      </p:pic>
+    </p:spTree>
+  </p:cSld>
+  <p:clrMapOvr>
+    <a:masterClrMapping/>
+  </p:clrMapOvr>
+</p:sld>
+</file>
+
+<file path=ppt/slides/slide13.xml><?xml version="1.0" encoding="utf-8"?>
+<p:sld xmlns:a="http://schemas.openxmlformats.org/drawingml/2006/main" xmlns:p="http://schemas.openxmlformats.org/presentationml/2006/main" xmlns:r="http://schemas.openxmlformats.org/officeDocument/2006/relationships">
+  <p:cSld>
+    <p:spTree>
+      <p:nvGrpSpPr>
+        <p:cNvPr id="1" name=""/>
+        <p:cNvGrpSpPr/>
+        <p:nvPr/>
+      </p:nvGrpSpPr>
+      <p:grpSpPr/>
+      <p:pic>
+        <p:nvPicPr>
+          <p:cNvPr id="2" name="Picture 1" descr="slide-13.png"/>
+          <p:cNvPicPr>
+            <a:picLocks noChangeAspect="1"/>
+          </p:cNvPicPr>
+          <p:nvPr/>
+        </p:nvPicPr>
+        <p:blipFill>
+          <a:blip r:embed="rId2"/>
+          <a:stretch>
+            <a:fillRect/>
+          </a:stretch>
+        </p:blipFill>
+        <p:spPr>
+          <a:xfrm>
+            <a:off x="0" y="0"/>
+            <a:ext cx="9144000" cy="6858000"/>
+          </a:xfrm>
+          <a:prstGeom prst="rect">
+            <a:avLst/>
+          </a:prstGeom>
+        </p:spPr>
+      </p:pic>
+    </p:spTree>
+  </p:cSld>
+  <p:clrMapOvr>
+    <a:masterClrMapping/>
+  </p:clrMapOvr>
+</p:sld>
+</file>
+
+<file path=ppt/slides/slide14.xml><?xml version="1.0" encoding="utf-8"?>
+<p:sld xmlns:a="http://schemas.openxmlformats.org/drawingml/2006/main" xmlns:p="http://schemas.openxmlformats.org/presentationml/2006/main" xmlns:r="http://schemas.openxmlformats.org/officeDocument/2006/relationships">
+  <p:cSld>
+    <p:spTree>
+      <p:nvGrpSpPr>
+        <p:cNvPr id="1" name=""/>
+        <p:cNvGrpSpPr/>
+        <p:nvPr/>
+      </p:nvGrpSpPr>
+      <p:grpSpPr/>
+      <p:pic>
+        <p:nvPicPr>
+          <p:cNvPr id="2" name="Picture 1" descr="slide-14.png"/>
+          <p:cNvPicPr>
+            <a:picLocks noChangeAspect="1"/>
+          </p:cNvPicPr>
+          <p:nvPr/>
+        </p:nvPicPr>
+        <p:blipFill>
+          <a:blip r:embed="rId2"/>
+          <a:stretch>
+            <a:fillRect/>
+          </a:stretch>
+        </p:blipFill>
+        <p:spPr>
+          <a:xfrm>
+            <a:off x="0" y="0"/>
+            <a:ext cx="9144000" cy="6858000"/>
+          </a:xfrm>
+          <a:prstGeom prst="rect">
+            <a:avLst/>
+          </a:prstGeom>
+        </p:spPr>
+      </p:pic>
+    </p:spTree>
+  </p:cSld>
+  <p:clrMapOvr>
+    <a:masterClrMapping/>
+  </p:clrMapOvr>
+</p:sld>
+</file>
+
+<file path=ppt/slides/slide15.xml><?xml version="1.0" encoding="utf-8"?>
+<p:sld xmlns:a="http://schemas.openxmlformats.org/drawingml/2006/main" xmlns:p="http://schemas.openxmlformats.org/presentationml/2006/main" xmlns:r="http://schemas.openxmlformats.org/officeDocument/2006/relationships">
+  <p:cSld>
+    <p:spTree>
+      <p:nvGrpSpPr>
+        <p:cNvPr id="1" name=""/>
+        <p:cNvGrpSpPr/>
+        <p:nvPr/>
+      </p:nvGrpSpPr>
+      <p:grpSpPr/>
+      <p:pic>
+        <p:nvPicPr>
+          <p:cNvPr id="2" name="Picture 1" descr="slide-15.png"/>
+          <p:cNvPicPr>
+            <a:picLocks noChangeAspect="1"/>
+          </p:cNvPicPr>
+          <p:nvPr/>
+        </p:nvPicPr>
+        <p:blipFill>
+          <a:blip r:embed="rId2"/>
+          <a:stretch>
+            <a:fillRect/>
+          </a:stretch>
+        </p:blipFill>
+        <p:spPr>
+          <a:xfrm>
+            <a:off x="0" y="0"/>
+            <a:ext cx="9144000" cy="6858000"/>
+          </a:xfrm>
+          <a:prstGeom prst="rect">
+            <a:avLst/>
+          </a:prstGeom>
+        </p:spPr>
+      </p:pic>
+    </p:spTree>
+  </p:cSld>
+  <p:clrMapOvr>
+    <a:masterClrMapping/>
+  </p:clrMapOvr>
+</p:sld>
+</file>
+
+<file path=ppt/slides/slide16.xml><?xml version="1.0" encoding="utf-8"?>
+<p:sld xmlns:a="http://schemas.openxmlformats.org/drawingml/2006/main" xmlns:p="http://schemas.openxmlformats.org/presentationml/2006/main" xmlns:r="http://schemas.openxmlformats.org/officeDocument/2006/relationships">
+  <p:cSld>
+    <p:spTree>
+      <p:nvGrpSpPr>
+        <p:cNvPr id="1" name=""/>
+        <p:cNvGrpSpPr/>
+        <p:nvPr/>
+      </p:nvGrpSpPr>
+      <p:grpSpPr/>
+      <p:pic>
+        <p:nvPicPr>
+          <p:cNvPr id="2" name="Picture 1" descr="slide-16.png"/>
+          <p:cNvPicPr>
+            <a:picLocks noChangeAspect="1"/>
+          </p:cNvPicPr>
+          <p:nvPr/>
+        </p:nvPicPr>
+        <p:blipFill>
+          <a:blip r:embed="rId2"/>
+          <a:stretch>
+            <a:fillRect/>
+          </a:stretch>
+        </p:blipFill>
+        <p:spPr>
+          <a:xfrm>
+            <a:off x="0" y="0"/>
+            <a:ext cx="9144000" cy="6858000"/>
+          </a:xfrm>
+          <a:prstGeom prst="rect">
+            <a:avLst/>
+          </a:prstGeom>
+        </p:spPr>
+      </p:pic>
+    </p:spTree>
+  </p:cSld>
+  <p:clrMapOvr>
+    <a:masterClrMapping/>
+  </p:clrMapOvr>
+</p:sld>
+</file>
+
+<file path=ppt/slides/slide17.xml><?xml version="1.0" encoding="utf-8"?>
+<p:sld xmlns:a="http://schemas.openxmlformats.org/drawingml/2006/main" xmlns:p="http://schemas.openxmlformats.org/presentationml/2006/main" xmlns:r="http://schemas.openxmlformats.org/officeDocument/2006/relationships">
+  <p:cSld>
+    <p:spTree>
+      <p:nvGrpSpPr>
+        <p:cNvPr id="1" name=""/>
+        <p:cNvGrpSpPr/>
+        <p:nvPr/>
+      </p:nvGrpSpPr>
+      <p:grpSpPr/>
+      <p:pic>
+        <p:nvPicPr>
+          <p:cNvPr id="2" name="Picture 1" descr="slide-17.png"/>
+          <p:cNvPicPr>
+            <a:picLocks noChangeAspect="1"/>
+          </p:cNvPicPr>
+          <p:nvPr/>
+        </p:nvPicPr>
+        <p:blipFill>
+          <a:blip r:embed="rId2"/>
+          <a:stretch>
+            <a:fillRect/>
+          </a:stretch>
+        </p:blipFill>
+        <p:spPr>
+          <a:xfrm>
+            <a:off x="0" y="0"/>
+            <a:ext cx="9144000" cy="6858000"/>
+          </a:xfrm>
+          <a:prstGeom prst="rect">
+            <a:avLst/>
+          </a:prstGeom>
+        </p:spPr>
+      </p:pic>
+    </p:spTree>
+  </p:cSld>
+  <p:clrMapOvr>
+    <a:masterClrMapping/>
+  </p:clrMapOvr>
+</p:sld>
+</file>
+
+<file path=ppt/slides/slide18.xml><?xml version="1.0" encoding="utf-8"?>
+<p:sld xmlns:a="http://schemas.openxmlformats.org/drawingml/2006/main" xmlns:p="http://schemas.openxmlformats.org/presentationml/2006/main" xmlns:r="http://schemas.openxmlformats.org/officeDocument/2006/relationships">
+  <p:cSld>
+    <p:spTree>
+      <p:nvGrpSpPr>
+        <p:cNvPr id="1" name=""/>
+        <p:cNvGrpSpPr/>
+        <p:nvPr/>
+      </p:nvGrpSpPr>
+      <p:grpSpPr/>
+      <p:pic>
+        <p:nvPicPr>
+          <p:cNvPr id="2" name="Picture 1" descr="slide-18.png"/>
+          <p:cNvPicPr>
+            <a:picLocks noChangeAspect="1"/>
+          </p:cNvPicPr>
+          <p:nvPr/>
+        </p:nvPicPr>
+        <p:blipFill>
+          <a:blip r:embed="rId2"/>
+          <a:stretch>
+            <a:fillRect/>
+          </a:stretch>
+        </p:blipFill>
+        <p:spPr>
+          <a:xfrm>
+            <a:off x="0" y="0"/>
+            <a:ext cx="9144000" cy="6858000"/>
+          </a:xfrm>
+          <a:prstGeom prst="rect">
+            <a:avLst/>
+          </a:prstGeom>
+        </p:spPr>
+      </p:pic>
+    </p:spTree>
+  </p:cSld>
+  <p:clrMapOvr>
+    <a:masterClrMapping/>
+  </p:clrMapOvr>
+</p:sld>
+</file>
+
+<file path=ppt/slides/slide19.xml><?xml version="1.0" encoding="utf-8"?>
+<p:sld xmlns:a="http://schemas.openxmlformats.org/drawingml/2006/main" xmlns:p="http://schemas.openxmlformats.org/presentationml/2006/main" xmlns:r="http://schemas.openxmlformats.org/officeDocument/2006/relationships">
+  <p:cSld>
+    <p:spTree>
+      <p:nvGrpSpPr>
+        <p:cNvPr id="1" name=""/>
+        <p:cNvGrpSpPr/>
+        <p:nvPr/>
+      </p:nvGrpSpPr>
+      <p:grpSpPr/>
+      <p:pic>
+        <p:nvPicPr>
+          <p:cNvPr id="2" name="Picture 1" descr="slide-19.png"/>
+          <p:cNvPicPr>
+            <a:picLocks noChangeAspect="1"/>
+          </p:cNvPicPr>
+          <p:nvPr/>
+        </p:nvPicPr>
+        <p:blipFill>
+          <a:blip r:embed="rId2"/>
+          <a:stretch>
+            <a:fillRect/>
+          </a:stretch>
+        </p:blipFill>
+        <p:spPr>
+          <a:xfrm>
+            <a:off x="0" y="0"/>
+            <a:ext cx="9144000" cy="6858000"/>
+          </a:xfrm>
+          <a:prstGeom prst="rect">
+            <a:avLst/>
+          </a:prstGeom>
+        </p:spPr>
+      </p:pic>
     </p:spTree>
   </p:cSld>
   <p:clrMapOvr>
@@ -3590,124 +3578,450 @@
         <p:nvPr/>
       </p:nvGrpSpPr>
       <p:grpSpPr/>
-      <p:sp>
-        <p:nvSpPr>
-          <p:cNvPr id="2" name="Title 1"/>
-          <p:cNvSpPr>
-            <a:spLocks noGrp="1"/>
-          </p:cNvSpPr>
-          <p:nvPr>
-            <p:ph type="title"/>
-          </p:nvPr>
-        </p:nvSpPr>
-        <p:spPr/>
-        <p:txBody>
-          <a:bodyPr/>
-          <a:lstStyle/>
-          <a:p>
-            <a:pPr>
-              <a:defRPr sz="3600">
-                <a:solidFill>
-                  <a:srgbClr val="1A1A2E"/>
-                </a:solidFill>
-              </a:defRPr>
-            </a:pPr>
-            <a:r>
-              <a:t>Business Question</a:t>
-            </a:r>
-          </a:p>
-        </p:txBody>
-      </p:sp>
-      <p:sp>
-        <p:nvSpPr>
-          <p:cNvPr id="3" name="Content Placeholder 2"/>
-          <p:cNvSpPr>
-            <a:spLocks noGrp="1"/>
-          </p:cNvSpPr>
-          <p:nvPr>
-            <p:ph idx="1"/>
-          </p:nvPr>
-        </p:nvSpPr>
-        <p:spPr/>
-        <p:txBody>
-          <a:bodyPr/>
-          <a:lstStyle/>
-          <a:p>
-            <a:pPr>
-              <a:defRPr sz="2000"/>
-            </a:pPr>
-            <a:r>
-              <a:t>Given a customer's profile and current browsing/cart behavior,</a:t>
-            </a:r>
-          </a:p>
-          <a:p>
-            <a:pPr>
-              <a:defRPr sz="2000"/>
-            </a:pPr>
-            <a:r>
-              <a:t>what is the expected value of this order?</a:t>
-            </a:r>
-          </a:p>
-          <a:p>
-            <a:pPr>
-              <a:defRPr sz="2000"/>
-            </a:pPr>
-          </a:p>
-          <a:p>
-            <a:pPr>
-              <a:defRPr sz="2000"/>
-            </a:pPr>
-            <a:r>
-              <a:t>Why it matters:</a:t>
-            </a:r>
-          </a:p>
-          <a:p>
-            <a:pPr>
-              <a:defRPr sz="2000"/>
-            </a:pPr>
-            <a:r>
-              <a:t>• Dynamic upsell recommendations at checkout</a:t>
-            </a:r>
-          </a:p>
-          <a:p>
-            <a:pPr>
-              <a:defRPr sz="2000"/>
-            </a:pPr>
-            <a:r>
-              <a:t>• Optimized shipping &amp; insurance options</a:t>
-            </a:r>
-          </a:p>
-          <a:p>
-            <a:pPr>
-              <a:defRPr sz="2000"/>
-            </a:pPr>
-            <a:r>
-              <a:t>• Targeted promotions by predicted value tier</a:t>
-            </a:r>
-          </a:p>
-          <a:p>
-            <a:pPr>
-              <a:defRPr sz="2000"/>
-            </a:pPr>
-          </a:p>
-          <a:p>
-            <a:pPr>
-              <a:defRPr sz="2000"/>
-            </a:pPr>
-            <a:r>
-              <a:t>Data: Olist Brazilian E-Commerce (99K orders)</a:t>
-            </a:r>
-          </a:p>
-          <a:p>
-            <a:pPr>
-              <a:defRPr sz="2000"/>
-            </a:pPr>
-            <a:r>
-              <a:t>+ Synthetic behavioral data (96K profiles, 99K sessions, 764K events)</a:t>
-            </a:r>
-          </a:p>
-        </p:txBody>
-      </p:sp>
+      <p:pic>
+        <p:nvPicPr>
+          <p:cNvPr id="2" name="Picture 1" descr="slide-02.png"/>
+          <p:cNvPicPr>
+            <a:picLocks noChangeAspect="1"/>
+          </p:cNvPicPr>
+          <p:nvPr/>
+        </p:nvPicPr>
+        <p:blipFill>
+          <a:blip r:embed="rId2"/>
+          <a:stretch>
+            <a:fillRect/>
+          </a:stretch>
+        </p:blipFill>
+        <p:spPr>
+          <a:xfrm>
+            <a:off x="0" y="0"/>
+            <a:ext cx="9144000" cy="6858000"/>
+          </a:xfrm>
+          <a:prstGeom prst="rect">
+            <a:avLst/>
+          </a:prstGeom>
+        </p:spPr>
+      </p:pic>
+    </p:spTree>
+  </p:cSld>
+  <p:clrMapOvr>
+    <a:masterClrMapping/>
+  </p:clrMapOvr>
+</p:sld>
+</file>
+
+<file path=ppt/slides/slide20.xml><?xml version="1.0" encoding="utf-8"?>
+<p:sld xmlns:a="http://schemas.openxmlformats.org/drawingml/2006/main" xmlns:p="http://schemas.openxmlformats.org/presentationml/2006/main" xmlns:r="http://schemas.openxmlformats.org/officeDocument/2006/relationships">
+  <p:cSld>
+    <p:spTree>
+      <p:nvGrpSpPr>
+        <p:cNvPr id="1" name=""/>
+        <p:cNvGrpSpPr/>
+        <p:nvPr/>
+      </p:nvGrpSpPr>
+      <p:grpSpPr/>
+      <p:pic>
+        <p:nvPicPr>
+          <p:cNvPr id="2" name="Picture 1" descr="slide-20.png"/>
+          <p:cNvPicPr>
+            <a:picLocks noChangeAspect="1"/>
+          </p:cNvPicPr>
+          <p:nvPr/>
+        </p:nvPicPr>
+        <p:blipFill>
+          <a:blip r:embed="rId2"/>
+          <a:stretch>
+            <a:fillRect/>
+          </a:stretch>
+        </p:blipFill>
+        <p:spPr>
+          <a:xfrm>
+            <a:off x="0" y="0"/>
+            <a:ext cx="9144000" cy="6858000"/>
+          </a:xfrm>
+          <a:prstGeom prst="rect">
+            <a:avLst/>
+          </a:prstGeom>
+        </p:spPr>
+      </p:pic>
+    </p:spTree>
+  </p:cSld>
+  <p:clrMapOvr>
+    <a:masterClrMapping/>
+  </p:clrMapOvr>
+</p:sld>
+</file>
+
+<file path=ppt/slides/slide21.xml><?xml version="1.0" encoding="utf-8"?>
+<p:sld xmlns:a="http://schemas.openxmlformats.org/drawingml/2006/main" xmlns:p="http://schemas.openxmlformats.org/presentationml/2006/main" xmlns:r="http://schemas.openxmlformats.org/officeDocument/2006/relationships">
+  <p:cSld>
+    <p:spTree>
+      <p:nvGrpSpPr>
+        <p:cNvPr id="1" name=""/>
+        <p:cNvGrpSpPr/>
+        <p:nvPr/>
+      </p:nvGrpSpPr>
+      <p:grpSpPr/>
+      <p:pic>
+        <p:nvPicPr>
+          <p:cNvPr id="2" name="Picture 1" descr="slide-21.png"/>
+          <p:cNvPicPr>
+            <a:picLocks noChangeAspect="1"/>
+          </p:cNvPicPr>
+          <p:nvPr/>
+        </p:nvPicPr>
+        <p:blipFill>
+          <a:blip r:embed="rId2"/>
+          <a:stretch>
+            <a:fillRect/>
+          </a:stretch>
+        </p:blipFill>
+        <p:spPr>
+          <a:xfrm>
+            <a:off x="0" y="0"/>
+            <a:ext cx="9144000" cy="6858000"/>
+          </a:xfrm>
+          <a:prstGeom prst="rect">
+            <a:avLst/>
+          </a:prstGeom>
+        </p:spPr>
+      </p:pic>
+    </p:spTree>
+  </p:cSld>
+  <p:clrMapOvr>
+    <a:masterClrMapping/>
+  </p:clrMapOvr>
+</p:sld>
+</file>
+
+<file path=ppt/slides/slide22.xml><?xml version="1.0" encoding="utf-8"?>
+<p:sld xmlns:a="http://schemas.openxmlformats.org/drawingml/2006/main" xmlns:p="http://schemas.openxmlformats.org/presentationml/2006/main" xmlns:r="http://schemas.openxmlformats.org/officeDocument/2006/relationships">
+  <p:cSld>
+    <p:spTree>
+      <p:nvGrpSpPr>
+        <p:cNvPr id="1" name=""/>
+        <p:cNvGrpSpPr/>
+        <p:nvPr/>
+      </p:nvGrpSpPr>
+      <p:grpSpPr/>
+      <p:pic>
+        <p:nvPicPr>
+          <p:cNvPr id="2" name="Picture 1" descr="slide-22.png"/>
+          <p:cNvPicPr>
+            <a:picLocks noChangeAspect="1"/>
+          </p:cNvPicPr>
+          <p:nvPr/>
+        </p:nvPicPr>
+        <p:blipFill>
+          <a:blip r:embed="rId2"/>
+          <a:stretch>
+            <a:fillRect/>
+          </a:stretch>
+        </p:blipFill>
+        <p:spPr>
+          <a:xfrm>
+            <a:off x="0" y="0"/>
+            <a:ext cx="9144000" cy="6858000"/>
+          </a:xfrm>
+          <a:prstGeom prst="rect">
+            <a:avLst/>
+          </a:prstGeom>
+        </p:spPr>
+      </p:pic>
+    </p:spTree>
+  </p:cSld>
+  <p:clrMapOvr>
+    <a:masterClrMapping/>
+  </p:clrMapOvr>
+</p:sld>
+</file>
+
+<file path=ppt/slides/slide23.xml><?xml version="1.0" encoding="utf-8"?>
+<p:sld xmlns:a="http://schemas.openxmlformats.org/drawingml/2006/main" xmlns:p="http://schemas.openxmlformats.org/presentationml/2006/main" xmlns:r="http://schemas.openxmlformats.org/officeDocument/2006/relationships">
+  <p:cSld>
+    <p:spTree>
+      <p:nvGrpSpPr>
+        <p:cNvPr id="1" name=""/>
+        <p:cNvGrpSpPr/>
+        <p:nvPr/>
+      </p:nvGrpSpPr>
+      <p:grpSpPr/>
+      <p:pic>
+        <p:nvPicPr>
+          <p:cNvPr id="2" name="Picture 1" descr="slide-23.png"/>
+          <p:cNvPicPr>
+            <a:picLocks noChangeAspect="1"/>
+          </p:cNvPicPr>
+          <p:nvPr/>
+        </p:nvPicPr>
+        <p:blipFill>
+          <a:blip r:embed="rId2"/>
+          <a:stretch>
+            <a:fillRect/>
+          </a:stretch>
+        </p:blipFill>
+        <p:spPr>
+          <a:xfrm>
+            <a:off x="0" y="0"/>
+            <a:ext cx="9144000" cy="6858000"/>
+          </a:xfrm>
+          <a:prstGeom prst="rect">
+            <a:avLst/>
+          </a:prstGeom>
+        </p:spPr>
+      </p:pic>
+    </p:spTree>
+  </p:cSld>
+  <p:clrMapOvr>
+    <a:masterClrMapping/>
+  </p:clrMapOvr>
+</p:sld>
+</file>
+
+<file path=ppt/slides/slide24.xml><?xml version="1.0" encoding="utf-8"?>
+<p:sld xmlns:a="http://schemas.openxmlformats.org/drawingml/2006/main" xmlns:p="http://schemas.openxmlformats.org/presentationml/2006/main" xmlns:r="http://schemas.openxmlformats.org/officeDocument/2006/relationships">
+  <p:cSld>
+    <p:spTree>
+      <p:nvGrpSpPr>
+        <p:cNvPr id="1" name=""/>
+        <p:cNvGrpSpPr/>
+        <p:nvPr/>
+      </p:nvGrpSpPr>
+      <p:grpSpPr/>
+      <p:pic>
+        <p:nvPicPr>
+          <p:cNvPr id="2" name="Picture 1" descr="slide-24.png"/>
+          <p:cNvPicPr>
+            <a:picLocks noChangeAspect="1"/>
+          </p:cNvPicPr>
+          <p:nvPr/>
+        </p:nvPicPr>
+        <p:blipFill>
+          <a:blip r:embed="rId2"/>
+          <a:stretch>
+            <a:fillRect/>
+          </a:stretch>
+        </p:blipFill>
+        <p:spPr>
+          <a:xfrm>
+            <a:off x="0" y="0"/>
+            <a:ext cx="9144000" cy="6858000"/>
+          </a:xfrm>
+          <a:prstGeom prst="rect">
+            <a:avLst/>
+          </a:prstGeom>
+        </p:spPr>
+      </p:pic>
+    </p:spTree>
+  </p:cSld>
+  <p:clrMapOvr>
+    <a:masterClrMapping/>
+  </p:clrMapOvr>
+</p:sld>
+</file>
+
+<file path=ppt/slides/slide25.xml><?xml version="1.0" encoding="utf-8"?>
+<p:sld xmlns:a="http://schemas.openxmlformats.org/drawingml/2006/main" xmlns:p="http://schemas.openxmlformats.org/presentationml/2006/main" xmlns:r="http://schemas.openxmlformats.org/officeDocument/2006/relationships">
+  <p:cSld>
+    <p:spTree>
+      <p:nvGrpSpPr>
+        <p:cNvPr id="1" name=""/>
+        <p:cNvGrpSpPr/>
+        <p:nvPr/>
+      </p:nvGrpSpPr>
+      <p:grpSpPr/>
+      <p:pic>
+        <p:nvPicPr>
+          <p:cNvPr id="2" name="Picture 1" descr="slide-25.png"/>
+          <p:cNvPicPr>
+            <a:picLocks noChangeAspect="1"/>
+          </p:cNvPicPr>
+          <p:nvPr/>
+        </p:nvPicPr>
+        <p:blipFill>
+          <a:blip r:embed="rId2"/>
+          <a:stretch>
+            <a:fillRect/>
+          </a:stretch>
+        </p:blipFill>
+        <p:spPr>
+          <a:xfrm>
+            <a:off x="0" y="0"/>
+            <a:ext cx="9144000" cy="6858000"/>
+          </a:xfrm>
+          <a:prstGeom prst="rect">
+            <a:avLst/>
+          </a:prstGeom>
+        </p:spPr>
+      </p:pic>
+    </p:spTree>
+  </p:cSld>
+  <p:clrMapOvr>
+    <a:masterClrMapping/>
+  </p:clrMapOvr>
+</p:sld>
+</file>
+
+<file path=ppt/slides/slide26.xml><?xml version="1.0" encoding="utf-8"?>
+<p:sld xmlns:a="http://schemas.openxmlformats.org/drawingml/2006/main" xmlns:p="http://schemas.openxmlformats.org/presentationml/2006/main" xmlns:r="http://schemas.openxmlformats.org/officeDocument/2006/relationships">
+  <p:cSld>
+    <p:spTree>
+      <p:nvGrpSpPr>
+        <p:cNvPr id="1" name=""/>
+        <p:cNvGrpSpPr/>
+        <p:nvPr/>
+      </p:nvGrpSpPr>
+      <p:grpSpPr/>
+      <p:pic>
+        <p:nvPicPr>
+          <p:cNvPr id="2" name="Picture 1" descr="slide-26.png"/>
+          <p:cNvPicPr>
+            <a:picLocks noChangeAspect="1"/>
+          </p:cNvPicPr>
+          <p:nvPr/>
+        </p:nvPicPr>
+        <p:blipFill>
+          <a:blip r:embed="rId2"/>
+          <a:stretch>
+            <a:fillRect/>
+          </a:stretch>
+        </p:blipFill>
+        <p:spPr>
+          <a:xfrm>
+            <a:off x="0" y="0"/>
+            <a:ext cx="9144000" cy="6858000"/>
+          </a:xfrm>
+          <a:prstGeom prst="rect">
+            <a:avLst/>
+          </a:prstGeom>
+        </p:spPr>
+      </p:pic>
+    </p:spTree>
+  </p:cSld>
+  <p:clrMapOvr>
+    <a:masterClrMapping/>
+  </p:clrMapOvr>
+</p:sld>
+</file>
+
+<file path=ppt/slides/slide27.xml><?xml version="1.0" encoding="utf-8"?>
+<p:sld xmlns:a="http://schemas.openxmlformats.org/drawingml/2006/main" xmlns:p="http://schemas.openxmlformats.org/presentationml/2006/main" xmlns:r="http://schemas.openxmlformats.org/officeDocument/2006/relationships">
+  <p:cSld>
+    <p:spTree>
+      <p:nvGrpSpPr>
+        <p:cNvPr id="1" name=""/>
+        <p:cNvGrpSpPr/>
+        <p:nvPr/>
+      </p:nvGrpSpPr>
+      <p:grpSpPr/>
+      <p:pic>
+        <p:nvPicPr>
+          <p:cNvPr id="2" name="Picture 1" descr="slide-27.png"/>
+          <p:cNvPicPr>
+            <a:picLocks noChangeAspect="1"/>
+          </p:cNvPicPr>
+          <p:nvPr/>
+        </p:nvPicPr>
+        <p:blipFill>
+          <a:blip r:embed="rId2"/>
+          <a:stretch>
+            <a:fillRect/>
+          </a:stretch>
+        </p:blipFill>
+        <p:spPr>
+          <a:xfrm>
+            <a:off x="0" y="0"/>
+            <a:ext cx="9144000" cy="6858000"/>
+          </a:xfrm>
+          <a:prstGeom prst="rect">
+            <a:avLst/>
+          </a:prstGeom>
+        </p:spPr>
+      </p:pic>
+    </p:spTree>
+  </p:cSld>
+  <p:clrMapOvr>
+    <a:masterClrMapping/>
+  </p:clrMapOvr>
+</p:sld>
+</file>
+
+<file path=ppt/slides/slide28.xml><?xml version="1.0" encoding="utf-8"?>
+<p:sld xmlns:a="http://schemas.openxmlformats.org/drawingml/2006/main" xmlns:p="http://schemas.openxmlformats.org/presentationml/2006/main" xmlns:r="http://schemas.openxmlformats.org/officeDocument/2006/relationships">
+  <p:cSld>
+    <p:spTree>
+      <p:nvGrpSpPr>
+        <p:cNvPr id="1" name=""/>
+        <p:cNvGrpSpPr/>
+        <p:nvPr/>
+      </p:nvGrpSpPr>
+      <p:grpSpPr/>
+      <p:pic>
+        <p:nvPicPr>
+          <p:cNvPr id="2" name="Picture 1" descr="slide-28.png"/>
+          <p:cNvPicPr>
+            <a:picLocks noChangeAspect="1"/>
+          </p:cNvPicPr>
+          <p:nvPr/>
+        </p:nvPicPr>
+        <p:blipFill>
+          <a:blip r:embed="rId2"/>
+          <a:stretch>
+            <a:fillRect/>
+          </a:stretch>
+        </p:blipFill>
+        <p:spPr>
+          <a:xfrm>
+            <a:off x="0" y="0"/>
+            <a:ext cx="9144000" cy="6858000"/>
+          </a:xfrm>
+          <a:prstGeom prst="rect">
+            <a:avLst/>
+          </a:prstGeom>
+        </p:spPr>
+      </p:pic>
+    </p:spTree>
+  </p:cSld>
+  <p:clrMapOvr>
+    <a:masterClrMapping/>
+  </p:clrMapOvr>
+</p:sld>
+</file>
+
+<file path=ppt/slides/slide29.xml><?xml version="1.0" encoding="utf-8"?>
+<p:sld xmlns:a="http://schemas.openxmlformats.org/drawingml/2006/main" xmlns:p="http://schemas.openxmlformats.org/presentationml/2006/main" xmlns:r="http://schemas.openxmlformats.org/officeDocument/2006/relationships">
+  <p:cSld>
+    <p:spTree>
+      <p:nvGrpSpPr>
+        <p:cNvPr id="1" name=""/>
+        <p:cNvGrpSpPr/>
+        <p:nvPr/>
+      </p:nvGrpSpPr>
+      <p:grpSpPr/>
+      <p:pic>
+        <p:nvPicPr>
+          <p:cNvPr id="2" name="Picture 1" descr="slide-29.png"/>
+          <p:cNvPicPr>
+            <a:picLocks noChangeAspect="1"/>
+          </p:cNvPicPr>
+          <p:nvPr/>
+        </p:nvPicPr>
+        <p:blipFill>
+          <a:blip r:embed="rId2"/>
+          <a:stretch>
+            <a:fillRect/>
+          </a:stretch>
+        </p:blipFill>
+        <p:spPr>
+          <a:xfrm>
+            <a:off x="0" y="0"/>
+            <a:ext cx="9144000" cy="6858000"/>
+          </a:xfrm>
+          <a:prstGeom prst="rect">
+            <a:avLst/>
+          </a:prstGeom>
+        </p:spPr>
+      </p:pic>
     </p:spTree>
   </p:cSld>
   <p:clrMapOvr>
@@ -3726,146 +4040,30 @@
         <p:nvPr/>
       </p:nvGrpSpPr>
       <p:grpSpPr/>
-      <p:sp>
-        <p:nvSpPr>
-          <p:cNvPr id="2" name="Title 1"/>
-          <p:cNvSpPr>
-            <a:spLocks noGrp="1"/>
-          </p:cNvSpPr>
-          <p:nvPr>
-            <p:ph type="title"/>
-          </p:nvPr>
-        </p:nvSpPr>
-        <p:spPr/>
-        <p:txBody>
-          <a:bodyPr/>
-          <a:lstStyle/>
-          <a:p>
-            <a:pPr>
-              <a:defRPr sz="3600">
-                <a:solidFill>
-                  <a:srgbClr val="1A1A2E"/>
-                </a:solidFill>
-              </a:defRPr>
-            </a:pPr>
-            <a:r>
-              <a:t>Data Architecture</a:t>
-            </a:r>
-          </a:p>
-        </p:txBody>
-      </p:sp>
-      <p:sp>
-        <p:nvSpPr>
-          <p:cNvPr id="3" name="Content Placeholder 2"/>
-          <p:cNvSpPr>
-            <a:spLocks noGrp="1"/>
-          </p:cNvSpPr>
-          <p:nvPr>
-            <p:ph idx="1"/>
-          </p:nvPr>
-        </p:nvSpPr>
-        <p:spPr/>
-        <p:txBody>
-          <a:bodyPr/>
-          <a:lstStyle/>
-          <a:p>
-            <a:pPr>
-              <a:defRPr sz="2000"/>
-            </a:pPr>
-            <a:r>
-              <a:t>Olist Base Tables (Real)          Synthetic Extension (Generated)</a:t>
-            </a:r>
-          </a:p>
-          <a:p>
-            <a:pPr>
-              <a:defRPr sz="2000"/>
-            </a:pPr>
-            <a:r>
-              <a:t>┌─────────────────────┐          ┌──────────────────────────┐</a:t>
-            </a:r>
-          </a:p>
-          <a:p>
-            <a:pPr>
-              <a:defRPr sz="2000"/>
-            </a:pPr>
-            <a:r>
-              <a:t>│ orders (99K)        │          │ customer_profile (96K)   │</a:t>
-            </a:r>
-          </a:p>
-          <a:p>
-            <a:pPr>
-              <a:defRPr sz="2000"/>
-            </a:pPr>
-            <a:r>
-              <a:t>│ order_items (112K)  │──────┐   │ sessions (99K)           │</a:t>
-            </a:r>
-          </a:p>
-          <a:p>
-            <a:pPr>
-              <a:defRPr sz="2000"/>
-            </a:pPr>
-            <a:r>
-              <a:t>│ customers (99K)     │    │   │ session_activity (764K)  │</a:t>
-            </a:r>
-          </a:p>
-          <a:p>
-            <a:pPr>
-              <a:defRPr sz="2000"/>
-            </a:pPr>
-            <a:r>
-              <a:t>│ products (32K)      │    │   └──────────────────────────┘</a:t>
-            </a:r>
-          </a:p>
-          <a:p>
-            <a:pPr>
-              <a:defRPr sz="2000"/>
-            </a:pPr>
-            <a:r>
-              <a:t>│ sellers (3K)        │    │              │</a:t>
-            </a:r>
-          </a:p>
-          <a:p>
-            <a:pPr>
-              <a:defRPr sz="2000"/>
-            </a:pPr>
-            <a:r>
-              <a:t>│ geolocation (1M)    │    │   Value-conditioned generation:</a:t>
-            </a:r>
-          </a:p>
-          <a:p>
-            <a:pPr>
-              <a:defRPr sz="2000"/>
-            </a:pPr>
-            <a:r>
-              <a:t>│ payments (103K)     │    │   features correlated with real</a:t>
-            </a:r>
-          </a:p>
-          <a:p>
-            <a:pPr>
-              <a:defRPr sz="2000"/>
-            </a:pPr>
-            <a:r>
-              <a:t>│ reviews (104K)      │    │   order value (not random noise)</a:t>
-            </a:r>
-          </a:p>
-          <a:p>
-            <a:pPr>
-              <a:defRPr sz="2000"/>
-            </a:pPr>
-            <a:r>
-              <a:t>└─────────────────────┘    │</a:t>
-            </a:r>
-          </a:p>
-          <a:p>
-            <a:pPr>
-              <a:defRPr sz="2000"/>
-            </a:pPr>
-            <a:r>
-              <a:t>                           └──→ 180 features after engineering</a:t>
-            </a:r>
-          </a:p>
-        </p:txBody>
-      </p:sp>
+      <p:pic>
+        <p:nvPicPr>
+          <p:cNvPr id="2" name="Picture 1" descr="slide-03.png"/>
+          <p:cNvPicPr>
+            <a:picLocks noChangeAspect="1"/>
+          </p:cNvPicPr>
+          <p:nvPr/>
+        </p:nvPicPr>
+        <p:blipFill>
+          <a:blip r:embed="rId2"/>
+          <a:stretch>
+            <a:fillRect/>
+          </a:stretch>
+        </p:blipFill>
+        <p:spPr>
+          <a:xfrm>
+            <a:off x="0" y="0"/>
+            <a:ext cx="9144000" cy="6858000"/>
+          </a:xfrm>
+          <a:prstGeom prst="rect">
+            <a:avLst/>
+          </a:prstGeom>
+        </p:spPr>
+      </p:pic>
     </p:spTree>
   </p:cSld>
   <p:clrMapOvr>
@@ -3884,147 +4082,30 @@
         <p:nvPr/>
       </p:nvGrpSpPr>
       <p:grpSpPr/>
-      <p:sp>
-        <p:nvSpPr>
-          <p:cNvPr id="2" name="Title 1"/>
-          <p:cNvSpPr>
-            <a:spLocks noGrp="1"/>
-          </p:cNvSpPr>
-          <p:nvPr>
-            <p:ph type="title"/>
-          </p:nvPr>
-        </p:nvSpPr>
-        <p:spPr/>
-        <p:txBody>
-          <a:bodyPr/>
-          <a:lstStyle/>
-          <a:p>
-            <a:pPr>
-              <a:defRPr sz="3600">
-                <a:solidFill>
-                  <a:srgbClr val="1A1A2E"/>
-                </a:solidFill>
-              </a:defRPr>
-            </a:pPr>
-            <a:r>
-              <a:t>Key Innovation: Value-Conditioned Generation</a:t>
-            </a:r>
-          </a:p>
-        </p:txBody>
-      </p:sp>
-      <p:sp>
-        <p:nvSpPr>
-          <p:cNvPr id="3" name="Content Placeholder 2"/>
-          <p:cNvSpPr>
-            <a:spLocks noGrp="1"/>
-          </p:cNvSpPr>
-          <p:nvPr>
-            <p:ph idx="1"/>
-          </p:nvPr>
-        </p:nvSpPr>
-        <p:spPr/>
-        <p:txBody>
-          <a:bodyPr/>
-          <a:lstStyle/>
-          <a:p>
-            <a:pPr>
-              <a:defRPr sz="2000"/>
-            </a:pPr>
-            <a:r>
-              <a:t>Problem: Random synthetic features → zero correlation → model ignores them</a:t>
-            </a:r>
-          </a:p>
-          <a:p>
-            <a:pPr>
-              <a:defRPr sz="2000"/>
-            </a:pPr>
-          </a:p>
-          <a:p>
-            <a:pPr>
-              <a:defRPr sz="2000"/>
-            </a:pPr>
-            <a:r>
-              <a:t>Solution: Condition every feature on real order value</a:t>
-            </a:r>
-          </a:p>
-          <a:p>
-            <a:pPr>
-              <a:defRPr sz="2000"/>
-            </a:pPr>
-          </a:p>
-          <a:p>
-            <a:pPr>
-              <a:defRPr sz="2000"/>
-            </a:pPr>
-            <a:r>
-              <a:t>  monthly_income = exp(log(2500) + 0.35 × zscore(log(value)) + noise)</a:t>
-            </a:r>
-          </a:p>
-          <a:p>
-            <a:pPr>
-              <a:defRPr sz="2000"/>
-            </a:pPr>
-            <a:r>
-              <a:t>  → r = 0.51 with avg order value</a:t>
-            </a:r>
-          </a:p>
-          <a:p>
-            <a:pPr>
-              <a:defRPr sz="2000"/>
-            </a:pPr>
-          </a:p>
-          <a:p>
-            <a:pPr>
-              <a:defRPr sz="2000"/>
-            </a:pPr>
-            <a:r>
-              <a:t>  loyalty_tier: probabilities shift toward gold/platinum for high-value</a:t>
-            </a:r>
-          </a:p>
-          <a:p>
-            <a:pPr>
-              <a:defRPr sz="2000"/>
-            </a:pPr>
-            <a:r>
-              <a:t>  → 2.5× AOV spread (bronze R$82 → platinum R$202)</a:t>
-            </a:r>
-          </a:p>
-          <a:p>
-            <a:pPr>
-              <a:defRPr sz="2000"/>
-            </a:pPr>
-          </a:p>
-          <a:p>
-            <a:pPr>
-              <a:defRPr sz="2000"/>
-            </a:pPr>
-            <a:r>
-              <a:t>  traffic_source: email/direct up for high-value, google/social down</a:t>
-            </a:r>
-          </a:p>
-          <a:p>
-            <a:pPr>
-              <a:defRPr sz="2000"/>
-            </a:pPr>
-            <a:r>
-              <a:t>  → email R$146 vs google R$89 (+64%)</a:t>
-            </a:r>
-          </a:p>
-          <a:p>
-            <a:pPr>
-              <a:defRPr sz="2000"/>
-            </a:pPr>
-          </a:p>
-          <a:p>
-            <a:pPr>
-              <a:defRPr sz="2000"/>
-            </a:pPr>
-            <a:r>
-              <a:t>Result: 13/20 top model features are synthetic behavioral</a:t>
-            </a:r>
-          </a:p>
-        </p:txBody>
-      </p:sp>
+      <p:pic>
+        <p:nvPicPr>
+          <p:cNvPr id="2" name="Picture 1" descr="slide-04.png"/>
+          <p:cNvPicPr>
+            <a:picLocks noChangeAspect="1"/>
+          </p:cNvPicPr>
+          <p:nvPr/>
+        </p:nvPicPr>
+        <p:blipFill>
+          <a:blip r:embed="rId2"/>
+          <a:stretch>
+            <a:fillRect/>
+          </a:stretch>
+        </p:blipFill>
+        <p:spPr>
+          <a:xfrm>
+            <a:off x="0" y="0"/>
+            <a:ext cx="9144000" cy="6858000"/>
+          </a:xfrm>
+          <a:prstGeom prst="rect">
+            <a:avLst/>
+          </a:prstGeom>
+        </p:spPr>
+      </p:pic>
     </p:spTree>
   </p:cSld>
   <p:clrMapOvr>
@@ -4043,140 +4124,30 @@
         <p:nvPr/>
       </p:nvGrpSpPr>
       <p:grpSpPr/>
-      <p:sp>
-        <p:nvSpPr>
-          <p:cNvPr id="2" name="Title 1"/>
-          <p:cNvSpPr>
-            <a:spLocks noGrp="1"/>
-          </p:cNvSpPr>
-          <p:nvPr>
-            <p:ph type="title"/>
-          </p:nvPr>
-        </p:nvSpPr>
-        <p:spPr/>
-        <p:txBody>
-          <a:bodyPr/>
-          <a:lstStyle/>
-          <a:p>
-            <a:pPr>
-              <a:defRPr sz="3600">
-                <a:solidFill>
-                  <a:srgbClr val="1A1A2E"/>
-                </a:solidFill>
-              </a:defRPr>
-            </a:pPr>
-            <a:r>
-              <a:t>EDA Highlights</a:t>
-            </a:r>
-          </a:p>
-        </p:txBody>
-      </p:sp>
-      <p:sp>
-        <p:nvSpPr>
-          <p:cNvPr id="3" name="Content Placeholder 2"/>
-          <p:cNvSpPr>
-            <a:spLocks noGrp="1"/>
-          </p:cNvSpPr>
-          <p:nvPr>
-            <p:ph idx="1"/>
-          </p:nvPr>
-        </p:nvSpPr>
-        <p:spPr/>
-        <p:txBody>
-          <a:bodyPr/>
-          <a:lstStyle/>
-          <a:p>
-            <a:pPr>
-              <a:defRPr sz="2000"/>
-            </a:pPr>
-            <a:r>
-              <a:t>Target: Heavily right-skewed (skew=9.37)</a:t>
-            </a:r>
-          </a:p>
-          <a:p>
-            <a:pPr>
-              <a:defRPr sz="2000"/>
-            </a:pPr>
-            <a:r>
-              <a:t>  Median R$105 | Mean R$160 | Max R$13,664</a:t>
-            </a:r>
-          </a:p>
-          <a:p>
-            <a:pPr>
-              <a:defRPr sz="2000"/>
-            </a:pPr>
-            <a:r>
-              <a:t>  Log1p transform → skew=0.17 (near-normal)</a:t>
-            </a:r>
-          </a:p>
-          <a:p>
-            <a:pPr>
-              <a:defRPr sz="2000"/>
-            </a:pPr>
-          </a:p>
-          <a:p>
-            <a:pPr>
-              <a:defRPr sz="2000"/>
-            </a:pPr>
-            <a:r>
-              <a:t>Top Drivers:</a:t>
-            </a:r>
-          </a:p>
-          <a:p>
-            <a:pPr>
-              <a:defRPr sz="2000"/>
-            </a:pPr>
-            <a:r>
-              <a:t>  Category:    Computers R$1,251 vs Office R$30 (40×)</a:t>
-            </a:r>
-          </a:p>
-          <a:p>
-            <a:pPr>
-              <a:defRPr sz="2000"/>
-            </a:pPr>
-            <a:r>
-              <a:t>  Loyalty:     Bronze R$82 → Platinum R$202 (2.5×)</a:t>
-            </a:r>
-          </a:p>
-          <a:p>
-            <a:pPr>
-              <a:defRPr sz="2000"/>
-            </a:pPr>
-            <a:r>
-              <a:t>  Traffic:     Email R$146 vs Google R$89 (+64%)</a:t>
-            </a:r>
-          </a:p>
-          <a:p>
-            <a:pPr>
-              <a:defRPr sz="2000"/>
-            </a:pPr>
-            <a:r>
-              <a:t>  Device:      Desktop R$110 vs Mobile R$103 (+7%)</a:t>
-            </a:r>
-          </a:p>
-          <a:p>
-            <a:pPr>
-              <a:defRPr sz="2000"/>
-            </a:pPr>
-          </a:p>
-          <a:p>
-            <a:pPr>
-              <a:defRPr sz="2000"/>
-            </a:pPr>
-            <a:r>
-              <a:t>No multicollinearity (|r| &lt; 0.7 for all feature pairs)</a:t>
-            </a:r>
-          </a:p>
-          <a:p>
-            <a:pPr>
-              <a:defRPr sz="2000"/>
-            </a:pPr>
-            <a:r>
-              <a:t>avg_item_price (r=0.92) flagged as leakage → excluded</a:t>
-            </a:r>
-          </a:p>
-        </p:txBody>
-      </p:sp>
+      <p:pic>
+        <p:nvPicPr>
+          <p:cNvPr id="2" name="Picture 1" descr="slide-05.png"/>
+          <p:cNvPicPr>
+            <a:picLocks noChangeAspect="1"/>
+          </p:cNvPicPr>
+          <p:nvPr/>
+        </p:nvPicPr>
+        <p:blipFill>
+          <a:blip r:embed="rId2"/>
+          <a:stretch>
+            <a:fillRect/>
+          </a:stretch>
+        </p:blipFill>
+        <p:spPr>
+          <a:xfrm>
+            <a:off x="0" y="0"/>
+            <a:ext cx="9144000" cy="6858000"/>
+          </a:xfrm>
+          <a:prstGeom prst="rect">
+            <a:avLst/>
+          </a:prstGeom>
+        </p:spPr>
+      </p:pic>
     </p:spTree>
   </p:cSld>
   <p:clrMapOvr>
@@ -4195,151 +4166,30 @@
         <p:nvPr/>
       </p:nvGrpSpPr>
       <p:grpSpPr/>
-      <p:sp>
-        <p:nvSpPr>
-          <p:cNvPr id="2" name="Title 1"/>
-          <p:cNvSpPr>
-            <a:spLocks noGrp="1"/>
-          </p:cNvSpPr>
-          <p:nvPr>
-            <p:ph type="title"/>
-          </p:nvPr>
-        </p:nvSpPr>
-        <p:spPr/>
-        <p:txBody>
-          <a:bodyPr/>
-          <a:lstStyle/>
-          <a:p>
-            <a:pPr>
-              <a:defRPr sz="3600">
-                <a:solidFill>
-                  <a:srgbClr val="1A1A2E"/>
-                </a:solidFill>
-              </a:defRPr>
-            </a:pPr>
-            <a:r>
-              <a:t>Feature Engineering — 180 Features</a:t>
-            </a:r>
-          </a:p>
-        </p:txBody>
-      </p:sp>
-      <p:sp>
-        <p:nvSpPr>
-          <p:cNvPr id="3" name="Content Placeholder 2"/>
-          <p:cNvSpPr>
-            <a:spLocks noGrp="1"/>
-          </p:cNvSpPr>
-          <p:nvPr>
-            <p:ph idx="1"/>
-          </p:nvPr>
-        </p:nvSpPr>
-        <p:spPr/>
-        <p:txBody>
-          <a:bodyPr/>
-          <a:lstStyle/>
-          <a:p>
-            <a:pPr>
-              <a:defRPr sz="2000"/>
-            </a:pPr>
-            <a:r>
-              <a:t>One-hot encoded (131):  device, browser, OS, traffic, loyalty, category</a:t>
-            </a:r>
-          </a:p>
-          <a:p>
-            <a:pPr>
-              <a:defRPr sz="2000"/>
-            </a:pPr>
-            <a:r>
-              <a:t>Scaled numerical (40):  income, session metrics, geo, seller, RFM, product</a:t>
-            </a:r>
-          </a:p>
-          <a:p>
-            <a:pPr>
-              <a:defRPr sz="2000"/>
-            </a:pPr>
-            <a:r>
-              <a:t>Target encoded (3):     ip_region, campaign_name, seller_state</a:t>
-            </a:r>
-          </a:p>
-          <a:p>
-            <a:pPr>
-              <a:defRPr sz="2000"/>
-            </a:pPr>
-            <a:r>
-              <a:t>Derived (17):           income×loyalty, cart_conversion, distance_per_item</a:t>
-            </a:r>
-          </a:p>
-          <a:p>
-            <a:pPr>
-              <a:defRPr sz="2000"/>
-            </a:pPr>
-            <a:r>
-              <a:t>Boolean (2):            is_logged_in, is_marketing_opt_in</a:t>
-            </a:r>
-          </a:p>
-          <a:p>
-            <a:pPr>
-              <a:defRPr sz="2000"/>
-            </a:pPr>
-          </a:p>
-          <a:p>
-            <a:pPr>
-              <a:defRPr sz="2000"/>
-            </a:pPr>
-            <a:r>
-              <a:t>V2 Additions (6 new data sources):</a:t>
-            </a:r>
-          </a:p>
-          <a:p>
-            <a:pPr>
-              <a:defRPr sz="2000"/>
-            </a:pPr>
-            <a:r>
-              <a:t>  ✓ Geolocation: haversine distance, urban/rural, regional price index</a:t>
-            </a:r>
-          </a:p>
-          <a:p>
-            <a:pPr>
-              <a:defRPr sz="2000"/>
-            </a:pPr>
-            <a:r>
-              <a:t>  ✓ Seller: order count, avg price, category specialization</a:t>
-            </a:r>
-          </a:p>
-          <a:p>
-            <a:pPr>
-              <a:defRPr sz="2000"/>
-            </a:pPr>
-            <a:r>
-              <a:t>  ✓ RFM: customer age, recency, frequency, seasonality</a:t>
-            </a:r>
-          </a:p>
-          <a:p>
-            <a:pPr>
-              <a:defRPr sz="2000"/>
-            </a:pPr>
-            <a:r>
-              <a:t>  ✓ Product: category avg/std price, order count</a:t>
-            </a:r>
-          </a:p>
-          <a:p>
-            <a:pPr>
-              <a:defRPr sz="2000"/>
-            </a:pPr>
-            <a:r>
-              <a:t>  ✓ No winsorization (raw value preserved)</a:t>
-            </a:r>
-          </a:p>
-          <a:p>
-            <a:pPr>
-              <a:defRPr sz="2000"/>
-            </a:pPr>
-            <a:r>
-              <a:t>  ✓ Time-based split (no temporal leakage)</a:t>
-            </a:r>
-          </a:p>
-        </p:txBody>
-      </p:sp>
+      <p:pic>
+        <p:nvPicPr>
+          <p:cNvPr id="2" name="Picture 1" descr="slide-06.png"/>
+          <p:cNvPicPr>
+            <a:picLocks noChangeAspect="1"/>
+          </p:cNvPicPr>
+          <p:nvPr/>
+        </p:nvPicPr>
+        <p:blipFill>
+          <a:blip r:embed="rId2"/>
+          <a:stretch>
+            <a:fillRect/>
+          </a:stretch>
+        </p:blipFill>
+        <p:spPr>
+          <a:xfrm>
+            <a:off x="0" y="0"/>
+            <a:ext cx="9144000" cy="6858000"/>
+          </a:xfrm>
+          <a:prstGeom prst="rect">
+            <a:avLst/>
+          </a:prstGeom>
+        </p:spPr>
+      </p:pic>
     </p:spTree>
   </p:cSld>
   <p:clrMapOvr>
@@ -4358,148 +4208,30 @@
         <p:nvPr/>
       </p:nvGrpSpPr>
       <p:grpSpPr/>
-      <p:sp>
-        <p:nvSpPr>
-          <p:cNvPr id="2" name="Title 1"/>
-          <p:cNvSpPr>
-            <a:spLocks noGrp="1"/>
-          </p:cNvSpPr>
-          <p:nvPr>
-            <p:ph type="title"/>
-          </p:nvPr>
-        </p:nvSpPr>
-        <p:spPr/>
-        <p:txBody>
-          <a:bodyPr/>
-          <a:lstStyle/>
-          <a:p>
-            <a:pPr>
-              <a:defRPr sz="3600">
-                <a:solidFill>
-                  <a:srgbClr val="1A1A2E"/>
-                </a:solidFill>
-              </a:defRPr>
-            </a:pPr>
-            <a:r>
-              <a:t>Model Results — Time-Based Split</a:t>
-            </a:r>
-          </a:p>
-        </p:txBody>
-      </p:sp>
-      <p:sp>
-        <p:nvSpPr>
-          <p:cNvPr id="3" name="Content Placeholder 2"/>
-          <p:cNvSpPr>
-            <a:spLocks noGrp="1"/>
-          </p:cNvSpPr>
-          <p:nvPr>
-            <p:ph idx="1"/>
-          </p:nvPr>
-        </p:nvSpPr>
-        <p:spPr/>
-        <p:txBody>
-          <a:bodyPr/>
-          <a:lstStyle/>
-          <a:p>
-            <a:pPr>
-              <a:defRPr sz="2000"/>
-            </a:pPr>
-            <a:r>
-              <a:t>Train: orders before 2018-04-01 | Test: orders after</a:t>
-            </a:r>
-          </a:p>
-          <a:p>
-            <a:pPr>
-              <a:defRPr sz="2000"/>
-            </a:pPr>
-            <a:r>
-              <a:t>Loss: L1 (MAE) for tree models — robust to outliers</a:t>
-            </a:r>
-          </a:p>
-          <a:p>
-            <a:pPr>
-              <a:defRPr sz="2000"/>
-            </a:pPr>
-          </a:p>
-          <a:p>
-            <a:pPr>
-              <a:defRPr sz="2000"/>
-            </a:pPr>
-            <a:r>
-              <a:t>  Model              R²     MAE(BRL)  WAPE   MedAPE</a:t>
-            </a:r>
-          </a:p>
-          <a:p>
-            <a:pPr>
-              <a:defRPr sz="2000"/>
-            </a:pPr>
-            <a:r>
-              <a:t>  ─────────────────  ─────  ────────  ─────  ──────</a:t>
-            </a:r>
-          </a:p>
-          <a:p>
-            <a:pPr>
-              <a:defRPr sz="2000"/>
-            </a:pPr>
-            <a:r>
-              <a:t>  Linear Regression  0.66   R$50      35%    29%</a:t>
-            </a:r>
-          </a:p>
-          <a:p>
-            <a:pPr>
-              <a:defRPr sz="2000"/>
-            </a:pPr>
-            <a:r>
-              <a:t>  Ridge              0.66   R$50      35%    29%</a:t>
-            </a:r>
-          </a:p>
-          <a:p>
-            <a:pPr>
-              <a:defRPr sz="2000"/>
-            </a:pPr>
-            <a:r>
-              <a:t>  Lasso              0.53   R$56      40%    35%</a:t>
-            </a:r>
-          </a:p>
-          <a:p>
-            <a:pPr>
-              <a:defRPr sz="2000"/>
-            </a:pPr>
-            <a:r>
-              <a:t>  Random Forest      0.66   R$45      32%    29%</a:t>
-            </a:r>
-          </a:p>
-          <a:p>
-            <a:pPr>
-              <a:defRPr sz="2000"/>
-            </a:pPr>
-            <a:r>
-              <a:t>  XGBoost (L1)       0.70   R$43      30%    27%  ← BEST</a:t>
-            </a:r>
-          </a:p>
-          <a:p>
-            <a:pPr>
-              <a:defRPr sz="2000"/>
-            </a:pPr>
-            <a:r>
-              <a:t>  LightGBM (MAE)     0.69   R$43      30%    27%</a:t>
-            </a:r>
-          </a:p>
-          <a:p>
-            <a:pPr>
-              <a:defRPr sz="2000"/>
-            </a:pPr>
-          </a:p>
-          <a:p>
-            <a:pPr>
-              <a:defRPr sz="2000"/>
-            </a:pPr>
-            <a:r>
-              <a:t>XGBoost explains 70% of variance in log-space</a:t>
-            </a:r>
-          </a:p>
-        </p:txBody>
-      </p:sp>
+      <p:pic>
+        <p:nvPicPr>
+          <p:cNvPr id="2" name="Picture 1" descr="slide-07.png"/>
+          <p:cNvPicPr>
+            <a:picLocks noChangeAspect="1"/>
+          </p:cNvPicPr>
+          <p:nvPr/>
+        </p:nvPicPr>
+        <p:blipFill>
+          <a:blip r:embed="rId2"/>
+          <a:stretch>
+            <a:fillRect/>
+          </a:stretch>
+        </p:blipFill>
+        <p:spPr>
+          <a:xfrm>
+            <a:off x="0" y="0"/>
+            <a:ext cx="9144000" cy="6858000"/>
+          </a:xfrm>
+          <a:prstGeom prst="rect">
+            <a:avLst/>
+          </a:prstGeom>
+        </p:spPr>
+      </p:pic>
     </p:spTree>
   </p:cSld>
   <p:clrMapOvr>
@@ -4518,164 +4250,30 @@
         <p:nvPr/>
       </p:nvGrpSpPr>
       <p:grpSpPr/>
-      <p:sp>
-        <p:nvSpPr>
-          <p:cNvPr id="2" name="Title 1"/>
-          <p:cNvSpPr>
-            <a:spLocks noGrp="1"/>
-          </p:cNvSpPr>
-          <p:nvPr>
-            <p:ph type="title"/>
-          </p:nvPr>
-        </p:nvSpPr>
-        <p:spPr/>
-        <p:txBody>
-          <a:bodyPr/>
-          <a:lstStyle/>
-          <a:p>
-            <a:pPr>
-              <a:defRPr sz="3600">
-                <a:solidFill>
-                  <a:srgbClr val="1A1A2E"/>
-                </a:solidFill>
-              </a:defRPr>
-            </a:pPr>
-            <a:r>
-              <a:t>Feature Importances — The Aha Moment</a:t>
-            </a:r>
-          </a:p>
-        </p:txBody>
-      </p:sp>
-      <p:sp>
-        <p:nvSpPr>
-          <p:cNvPr id="3" name="Content Placeholder 2"/>
-          <p:cNvSpPr>
-            <a:spLocks noGrp="1"/>
-          </p:cNvSpPr>
-          <p:nvPr>
-            <p:ph idx="1"/>
-          </p:nvPr>
-        </p:nvSpPr>
-        <p:spPr/>
-        <p:txBody>
-          <a:bodyPr/>
-          <a:lstStyle/>
-          <a:p>
-            <a:pPr>
-              <a:defRPr sz="2000"/>
-            </a:pPr>
-            <a:r>
-              <a:t>13 out of 20 top features are SYNTHETIC behavioral</a:t>
-            </a:r>
-          </a:p>
-          <a:p>
-            <a:pPr>
-              <a:defRPr sz="2000"/>
-            </a:pPr>
-          </a:p>
-          <a:p>
-            <a:pPr>
-              <a:defRPr sz="2000"/>
-            </a:pPr>
-            <a:r>
-              <a:t>  #1  income × loyalty      14.0%  ← synthetic interaction</a:t>
-            </a:r>
-          </a:p>
-          <a:p>
-            <a:pPr>
-              <a:defRPr sz="2000"/>
-            </a:pPr>
-            <a:r>
-              <a:t>  #2  n_events               8.8%  ← synthetic</a:t>
-            </a:r>
-          </a:p>
-          <a:p>
-            <a:pPr>
-              <a:defRPr sz="2000"/>
-            </a:pPr>
-            <a:r>
-              <a:t>  #3  n_add_to_cart          8.8%  ← synthetic</a:t>
-            </a:r>
-          </a:p>
-          <a:p>
-            <a:pPr>
-              <a:defRPr sz="2000"/>
-            </a:pPr>
-            <a:r>
-              <a:t>  #4  n_product_views        5.2%  ← synthetic</a:t>
-            </a:r>
-          </a:p>
-          <a:p>
-            <a:pPr>
-              <a:defRPr sz="2000"/>
-            </a:pPr>
-            <a:r>
-              <a:t>  #5  total_cart_qty         5.1%  ← synthetic</a:t>
-            </a:r>
-          </a:p>
-          <a:p>
-            <a:pPr>
-              <a:defRPr sz="2000"/>
-            </a:pPr>
-            <a:r>
-              <a:t>  #6  payment_installments   3.5%  ← real</a:t>
-            </a:r>
-          </a:p>
-          <a:p>
-            <a:pPr>
-              <a:defRPr sz="2000"/>
-            </a:pPr>
-            <a:r>
-              <a:t>  #7  category: telephony    2.7%  ← real</a:t>
-            </a:r>
-          </a:p>
-          <a:p>
-            <a:pPr>
-              <a:defRPr sz="2000"/>
-            </a:pPr>
-            <a:r>
-              <a:t>  #8  log_income             2.6%  ← synthetic</a:t>
-            </a:r>
-          </a:p>
-          <a:p>
-            <a:pPr>
-              <a:defRPr sz="2000"/>
-            </a:pPr>
-            <a:r>
-              <a:t>  #9  category: electronics  2.4%  ← real</a:t>
-            </a:r>
-          </a:p>
-          <a:p>
-            <a:pPr>
-              <a:defRPr sz="2000"/>
-            </a:pPr>
-            <a:r>
-              <a:t>  #10 loyalty_tier_bronze    2.3%  ← synthetic</a:t>
-            </a:r>
-          </a:p>
-          <a:p>
-            <a:pPr>
-              <a:defRPr sz="2000"/>
-            </a:pPr>
-          </a:p>
-          <a:p>
-            <a:pPr>
-              <a:defRPr sz="2000"/>
-            </a:pPr>
-            <a:r>
-              <a:t>The synthetic data isn't just realistic — it's the primary</a:t>
-            </a:r>
-          </a:p>
-          <a:p>
-            <a:pPr>
-              <a:defRPr sz="2000"/>
-            </a:pPr>
-            <a:r>
-              <a:t>driver of predictive power.</a:t>
-            </a:r>
-          </a:p>
-        </p:txBody>
-      </p:sp>
+      <p:pic>
+        <p:nvPicPr>
+          <p:cNvPr id="2" name="Picture 1" descr="slide-08.png"/>
+          <p:cNvPicPr>
+            <a:picLocks noChangeAspect="1"/>
+          </p:cNvPicPr>
+          <p:nvPr/>
+        </p:nvPicPr>
+        <p:blipFill>
+          <a:blip r:embed="rId2"/>
+          <a:stretch>
+            <a:fillRect/>
+          </a:stretch>
+        </p:blipFill>
+        <p:spPr>
+          <a:xfrm>
+            <a:off x="0" y="0"/>
+            <a:ext cx="9144000" cy="6858000"/>
+          </a:xfrm>
+          <a:prstGeom prst="rect">
+            <a:avLst/>
+          </a:prstGeom>
+        </p:spPr>
+      </p:pic>
     </p:spTree>
   </p:cSld>
   <p:clrMapOvr>
@@ -4694,145 +4292,30 @@
         <p:nvPr/>
       </p:nvGrpSpPr>
       <p:grpSpPr/>
-      <p:sp>
-        <p:nvSpPr>
-          <p:cNvPr id="2" name="Title 1"/>
-          <p:cNvSpPr>
-            <a:spLocks noGrp="1"/>
-          </p:cNvSpPr>
-          <p:nvPr>
-            <p:ph type="title"/>
-          </p:nvPr>
-        </p:nvSpPr>
-        <p:spPr/>
-        <p:txBody>
-          <a:bodyPr/>
-          <a:lstStyle/>
-          <a:p>
-            <a:pPr>
-              <a:defRPr sz="3600">
-                <a:solidFill>
-                  <a:srgbClr val="1A1A2E"/>
-                </a:solidFill>
-              </a:defRPr>
-            </a:pPr>
-            <a:r>
-              <a:t>Deployment — FastAPI + Streamlit</a:t>
-            </a:r>
-          </a:p>
-        </p:txBody>
-      </p:sp>
-      <p:sp>
-        <p:nvSpPr>
-          <p:cNvPr id="3" name="Content Placeholder 2"/>
-          <p:cNvSpPr>
-            <a:spLocks noGrp="1"/>
-          </p:cNvSpPr>
-          <p:nvPr>
-            <p:ph idx="1"/>
-          </p:nvPr>
-        </p:nvSpPr>
-        <p:spPr/>
-        <p:txBody>
-          <a:bodyPr/>
-          <a:lstStyle/>
-          <a:p>
-            <a:pPr>
-              <a:defRPr sz="2000"/>
-            </a:pPr>
-            <a:r>
-              <a:t>API: POST /predict → predicted value + 80% CI</a:t>
-            </a:r>
-          </a:p>
-          <a:p>
-            <a:pPr>
-              <a:defRPr sz="2000"/>
-            </a:pPr>
-            <a:r>
-              <a:t>  Input: 30+ features (customer, session, cart)</a:t>
-            </a:r>
-          </a:p>
-          <a:p>
-            <a:pPr>
-              <a:defRPr sz="2000"/>
-            </a:pPr>
-            <a:r>
-              <a:t>  Output: R$ value with confidence interval</a:t>
-            </a:r>
-          </a:p>
-          <a:p>
-            <a:pPr>
-              <a:defRPr sz="2000"/>
-            </a:pPr>
-          </a:p>
-          <a:p>
-            <a:pPr>
-              <a:defRPr sz="2000"/>
-            </a:pPr>
-            <a:r>
-              <a:t>Demo Results:</a:t>
-            </a:r>
-          </a:p>
-          <a:p>
-            <a:pPr>
-              <a:defRPr sz="2000"/>
-            </a:pPr>
-            <a:r>
-              <a:t>  Low profile  (bronze, mobile, 1 item)  → R$83</a:t>
-            </a:r>
-          </a:p>
-          <a:p>
-            <a:pPr>
-              <a:defRPr sz="2000"/>
-            </a:pPr>
-            <a:r>
-              <a:t>  High profile (platinum, desktop, 5 items) → R$520</a:t>
-            </a:r>
-          </a:p>
-          <a:p>
-            <a:pPr>
-              <a:defRPr sz="2000"/>
-            </a:pPr>
-            <a:r>
-              <a:t>  Spread: 6.3× — model differentiates profiles</a:t>
-            </a:r>
-          </a:p>
-          <a:p>
-            <a:pPr>
-              <a:defRPr sz="2000"/>
-            </a:pPr>
-          </a:p>
-          <a:p>
-            <a:pPr>
-              <a:defRPr sz="2000"/>
-            </a:pPr>
-            <a:r>
-              <a:t>Monitoring: PSI drift detection per feature</a:t>
-            </a:r>
-          </a:p>
-          <a:p>
-            <a:pPr>
-              <a:defRPr sz="2000"/>
-            </a:pPr>
-            <a:r>
-              <a:t>  Retraining triggers: PSI &gt; 0.25 or WAPE &gt; 35%</a:t>
-            </a:r>
-          </a:p>
-          <a:p>
-            <a:pPr>
-              <a:defRPr sz="2000"/>
-            </a:pPr>
-          </a:p>
-          <a:p>
-            <a:pPr>
-              <a:defRPr sz="2000"/>
-            </a:pPr>
-            <a:r>
-              <a:t>Reproducibility: bash run_pipeline.sh (one command)</a:t>
-            </a:r>
-          </a:p>
-        </p:txBody>
-      </p:sp>
+      <p:pic>
+        <p:nvPicPr>
+          <p:cNvPr id="2" name="Picture 1" descr="slide-09.png"/>
+          <p:cNvPicPr>
+            <a:picLocks noChangeAspect="1"/>
+          </p:cNvPicPr>
+          <p:nvPr/>
+        </p:nvPicPr>
+        <p:blipFill>
+          <a:blip r:embed="rId2"/>
+          <a:stretch>
+            <a:fillRect/>
+          </a:stretch>
+        </p:blipFill>
+        <p:spPr>
+          <a:xfrm>
+            <a:off x="0" y="0"/>
+            <a:ext cx="9144000" cy="6858000"/>
+          </a:xfrm>
+          <a:prstGeom prst="rect">
+            <a:avLst/>
+          </a:prstGeom>
+        </p:spPr>
+      </p:pic>
     </p:spTree>
   </p:cSld>
   <p:clrMapOvr>

</xml_diff>